<commit_message>
Mise à jour des cartes et des pistes de scores fr+en
</commit_message>
<xml_diff>
--- a/pictures/Score-Track-en/Design-Score-Track.pptx
+++ b/pictures/Score-Track-en/Design-Score-Track.pptx
@@ -198,7 +198,7 @@
           <a:p>
             <a:fld id="{263B0988-6DB9-4E3D-B7FD-EFF3BCABE954}" type="datetimeFigureOut">
               <a:rPr lang="fr-FR" smtClean="0"/>
-              <a:t>30/05/2026</a:t>
+              <a:t>16/09/2026</a:t>
             </a:fld>
             <a:endParaRPr lang="fr-FR"/>
           </a:p>
@@ -696,7 +696,7 @@
           <a:p>
             <a:fld id="{588505E2-0C4C-443F-8F57-41958F504CA2}" type="datetimeFigureOut">
               <a:rPr lang="fr-FR" smtClean="0"/>
-              <a:t>30/05/2026</a:t>
+              <a:t>16/09/2026</a:t>
             </a:fld>
             <a:endParaRPr lang="fr-FR"/>
           </a:p>
@@ -894,7 +894,7 @@
           <a:p>
             <a:fld id="{588505E2-0C4C-443F-8F57-41958F504CA2}" type="datetimeFigureOut">
               <a:rPr lang="fr-FR" smtClean="0"/>
-              <a:t>30/05/2026</a:t>
+              <a:t>16/09/2026</a:t>
             </a:fld>
             <a:endParaRPr lang="fr-FR"/>
           </a:p>
@@ -1102,7 +1102,7 @@
           <a:p>
             <a:fld id="{588505E2-0C4C-443F-8F57-41958F504CA2}" type="datetimeFigureOut">
               <a:rPr lang="fr-FR" smtClean="0"/>
-              <a:t>30/05/2026</a:t>
+              <a:t>16/09/2026</a:t>
             </a:fld>
             <a:endParaRPr lang="fr-FR"/>
           </a:p>
@@ -1300,7 +1300,7 @@
           <a:p>
             <a:fld id="{588505E2-0C4C-443F-8F57-41958F504CA2}" type="datetimeFigureOut">
               <a:rPr lang="fr-FR" smtClean="0"/>
-              <a:t>30/05/2026</a:t>
+              <a:t>16/09/2026</a:t>
             </a:fld>
             <a:endParaRPr lang="fr-FR"/>
           </a:p>
@@ -1575,7 +1575,7 @@
           <a:p>
             <a:fld id="{588505E2-0C4C-443F-8F57-41958F504CA2}" type="datetimeFigureOut">
               <a:rPr lang="fr-FR" smtClean="0"/>
-              <a:t>30/05/2026</a:t>
+              <a:t>16/09/2026</a:t>
             </a:fld>
             <a:endParaRPr lang="fr-FR"/>
           </a:p>
@@ -1840,7 +1840,7 @@
           <a:p>
             <a:fld id="{588505E2-0C4C-443F-8F57-41958F504CA2}" type="datetimeFigureOut">
               <a:rPr lang="fr-FR" smtClean="0"/>
-              <a:t>30/05/2026</a:t>
+              <a:t>16/09/2026</a:t>
             </a:fld>
             <a:endParaRPr lang="fr-FR"/>
           </a:p>
@@ -2252,7 +2252,7 @@
           <a:p>
             <a:fld id="{588505E2-0C4C-443F-8F57-41958F504CA2}" type="datetimeFigureOut">
               <a:rPr lang="fr-FR" smtClean="0"/>
-              <a:t>30/05/2026</a:t>
+              <a:t>16/09/2026</a:t>
             </a:fld>
             <a:endParaRPr lang="fr-FR"/>
           </a:p>
@@ -2393,7 +2393,7 @@
           <a:p>
             <a:fld id="{588505E2-0C4C-443F-8F57-41958F504CA2}" type="datetimeFigureOut">
               <a:rPr lang="fr-FR" smtClean="0"/>
-              <a:t>30/05/2026</a:t>
+              <a:t>16/09/2026</a:t>
             </a:fld>
             <a:endParaRPr lang="fr-FR"/>
           </a:p>
@@ -2506,7 +2506,7 @@
           <a:p>
             <a:fld id="{588505E2-0C4C-443F-8F57-41958F504CA2}" type="datetimeFigureOut">
               <a:rPr lang="fr-FR" smtClean="0"/>
-              <a:t>30/05/2026</a:t>
+              <a:t>16/09/2026</a:t>
             </a:fld>
             <a:endParaRPr lang="fr-FR"/>
           </a:p>
@@ -2817,7 +2817,7 @@
           <a:p>
             <a:fld id="{588505E2-0C4C-443F-8F57-41958F504CA2}" type="datetimeFigureOut">
               <a:rPr lang="fr-FR" smtClean="0"/>
-              <a:t>30/05/2026</a:t>
+              <a:t>16/09/2026</a:t>
             </a:fld>
             <a:endParaRPr lang="fr-FR"/>
           </a:p>
@@ -3105,7 +3105,7 @@
           <a:p>
             <a:fld id="{588505E2-0C4C-443F-8F57-41958F504CA2}" type="datetimeFigureOut">
               <a:rPr lang="fr-FR" smtClean="0"/>
-              <a:t>30/05/2026</a:t>
+              <a:t>16/09/2026</a:t>
             </a:fld>
             <a:endParaRPr lang="fr-FR"/>
           </a:p>
@@ -3346,7 +3346,7 @@
           <a:p>
             <a:fld id="{588505E2-0C4C-443F-8F57-41958F504CA2}" type="datetimeFigureOut">
               <a:rPr lang="fr-FR" smtClean="0"/>
-              <a:t>30/05/2026</a:t>
+              <a:t>16/09/2026</a:t>
             </a:fld>
             <a:endParaRPr lang="fr-FR"/>
           </a:p>
@@ -7567,6 +7567,7 @@
             </a:bodyPr>
             <a:lstStyle/>
             <a:p>
+              <a:pPr algn="ctr"/>
               <a:r>
                 <a:rPr lang="en-US" sz="1200" b="1" dirty="0">
                   <a:latin typeface="Segoe UI" panose="020B0502040204020203" pitchFamily="34" charset="0"/>
@@ -7603,7 +7604,7 @@
                   <a:cs typeface="Segoe UI" panose="020B0502040204020203" pitchFamily="34" charset="0"/>
                   <a:sym typeface="Wingdings" panose="05000000000000000000" pitchFamily="2" charset="2"/>
                 </a:rPr>
-                <a:t></a:t>
+                <a:t> </a:t>
               </a:r>
               <a:r>
                 <a:rPr lang="fr-FR" sz="1200" b="1" dirty="0">
@@ -7681,6 +7682,20 @@
             </a:bodyPr>
             <a:lstStyle/>
             <a:p>
+              <a:pPr algn="ctr"/>
+              <a:r>
+                <a:rPr lang="en-US" sz="1200" b="1" dirty="0">
+                  <a:latin typeface="Segoe UI" panose="020B0502040204020203" pitchFamily="34" charset="0"/>
+                  <a:cs typeface="Segoe UI" panose="020B0502040204020203" pitchFamily="34" charset="0"/>
+                </a:rPr>
+                <a:t>A player with </a:t>
+              </a:r>
+              <a:br>
+                <a:rPr lang="en-US" sz="1200" b="1" dirty="0">
+                  <a:latin typeface="Segoe UI" panose="020B0502040204020203" pitchFamily="34" charset="0"/>
+                  <a:cs typeface="Segoe UI" panose="020B0502040204020203" pitchFamily="34" charset="0"/>
+                </a:rPr>
+              </a:br>
               <a:r>
                 <a:rPr lang="en-US" sz="1200" b="1" dirty="0">
                   <a:solidFill>
@@ -7689,29 +7704,35 @@
                   <a:latin typeface="Segoe UI" panose="020B0502040204020203" pitchFamily="34" charset="0"/>
                   <a:cs typeface="Segoe UI" panose="020B0502040204020203" pitchFamily="34" charset="0"/>
                 </a:rPr>
-                <a:t>Heralds gathered </a:t>
+                <a:t>0 cards</a:t>
               </a:r>
               <a:r>
                 <a:rPr lang="en-US" sz="1200" b="1" dirty="0">
                   <a:latin typeface="Segoe UI" panose="020B0502040204020203" pitchFamily="34" charset="0"/>
                   <a:cs typeface="Segoe UI" panose="020B0502040204020203" pitchFamily="34" charset="0"/>
                 </a:rPr>
-                <a:t>at the Council ➔ </a:t>
+                <a:t> in hand </a:t>
               </a:r>
               <a:r>
-                <a:rPr lang="en-US" sz="1200" b="1" dirty="0">
+                <a:rPr lang="fr-FR" sz="1200" b="1" dirty="0">
+                  <a:latin typeface="Segoe UI" panose="020B0502040204020203" pitchFamily="34" charset="0"/>
+                  <a:cs typeface="Segoe UI" panose="020B0502040204020203" pitchFamily="34" charset="0"/>
+                  <a:sym typeface="Wingdings" panose="05000000000000000000" pitchFamily="2" charset="2"/>
+                </a:rPr>
+                <a:t> </a:t>
+              </a:r>
+              <a:r>
+                <a:rPr lang="fr-FR" sz="1200" b="1" dirty="0">
                   <a:solidFill>
                     <a:srgbClr val="FF0000"/>
                   </a:solidFill>
                   <a:latin typeface="Segoe UI" panose="020B0502040204020203" pitchFamily="34" charset="0"/>
                   <a:cs typeface="Segoe UI" panose="020B0502040204020203" pitchFamily="34" charset="0"/>
+                  <a:sym typeface="Wingdings" panose="05000000000000000000" pitchFamily="2" charset="2"/>
                 </a:rPr>
                 <a:t>STOP</a:t>
               </a:r>
               <a:endParaRPr lang="fr-FR" sz="1200" b="1" dirty="0">
-                <a:solidFill>
-                  <a:srgbClr val="FF0000"/>
-                </a:solidFill>
                 <a:latin typeface="Segoe UI" panose="020B0502040204020203" pitchFamily="34" charset="0"/>
                 <a:cs typeface="Segoe UI" panose="020B0502040204020203" pitchFamily="34" charset="0"/>
               </a:endParaRPr>

</xml_diff>